<commit_message>
Minor update to GPU docs
</commit_message>
<xml_diff>
--- a/docs/assets/images/GPU_What_GPU_is_right_for_your_job.pptx
+++ b/docs/assets/images/GPU_What_GPU_is_right_for_your_job.pptx
@@ -243,7 +243,7 @@
           <a:p>
             <a:fld id="{3E758BDC-CA1F-624E-AE4C-DC4ED6BCAE17}" type="datetimeFigureOut">
               <a:rPr lang="en-US" smtClean="0"/>
-              <a:t>5/16/26</a:t>
+              <a:t>5/26/26</a:t>
             </a:fld>
             <a:endParaRPr lang="en-US"/>
           </a:p>
@@ -413,7 +413,7 @@
           <a:p>
             <a:fld id="{3E758BDC-CA1F-624E-AE4C-DC4ED6BCAE17}" type="datetimeFigureOut">
               <a:rPr lang="en-US" smtClean="0"/>
-              <a:t>5/16/26</a:t>
+              <a:t>5/26/26</a:t>
             </a:fld>
             <a:endParaRPr lang="en-US"/>
           </a:p>
@@ -593,7 +593,7 @@
           <a:p>
             <a:fld id="{3E758BDC-CA1F-624E-AE4C-DC4ED6BCAE17}" type="datetimeFigureOut">
               <a:rPr lang="en-US" smtClean="0"/>
-              <a:t>5/16/26</a:t>
+              <a:t>5/26/26</a:t>
             </a:fld>
             <a:endParaRPr lang="en-US"/>
           </a:p>
@@ -763,7 +763,7 @@
           <a:p>
             <a:fld id="{3E758BDC-CA1F-624E-AE4C-DC4ED6BCAE17}" type="datetimeFigureOut">
               <a:rPr lang="en-US" smtClean="0"/>
-              <a:t>5/16/26</a:t>
+              <a:t>5/26/26</a:t>
             </a:fld>
             <a:endParaRPr lang="en-US"/>
           </a:p>
@@ -1009,7 +1009,7 @@
           <a:p>
             <a:fld id="{3E758BDC-CA1F-624E-AE4C-DC4ED6BCAE17}" type="datetimeFigureOut">
               <a:rPr lang="en-US" smtClean="0"/>
-              <a:t>5/16/26</a:t>
+              <a:t>5/26/26</a:t>
             </a:fld>
             <a:endParaRPr lang="en-US"/>
           </a:p>
@@ -1241,7 +1241,7 @@
           <a:p>
             <a:fld id="{3E758BDC-CA1F-624E-AE4C-DC4ED6BCAE17}" type="datetimeFigureOut">
               <a:rPr lang="en-US" smtClean="0"/>
-              <a:t>5/16/26</a:t>
+              <a:t>5/26/26</a:t>
             </a:fld>
             <a:endParaRPr lang="en-US"/>
           </a:p>
@@ -1608,7 +1608,7 @@
           <a:p>
             <a:fld id="{3E758BDC-CA1F-624E-AE4C-DC4ED6BCAE17}" type="datetimeFigureOut">
               <a:rPr lang="en-US" smtClean="0"/>
-              <a:t>5/16/26</a:t>
+              <a:t>5/26/26</a:t>
             </a:fld>
             <a:endParaRPr lang="en-US"/>
           </a:p>
@@ -1726,7 +1726,7 @@
           <a:p>
             <a:fld id="{3E758BDC-CA1F-624E-AE4C-DC4ED6BCAE17}" type="datetimeFigureOut">
               <a:rPr lang="en-US" smtClean="0"/>
-              <a:t>5/16/26</a:t>
+              <a:t>5/26/26</a:t>
             </a:fld>
             <a:endParaRPr lang="en-US"/>
           </a:p>
@@ -1821,7 +1821,7 @@
           <a:p>
             <a:fld id="{3E758BDC-CA1F-624E-AE4C-DC4ED6BCAE17}" type="datetimeFigureOut">
               <a:rPr lang="en-US" smtClean="0"/>
-              <a:t>5/16/26</a:t>
+              <a:t>5/26/26</a:t>
             </a:fld>
             <a:endParaRPr lang="en-US"/>
           </a:p>
@@ -2098,7 +2098,7 @@
           <a:p>
             <a:fld id="{3E758BDC-CA1F-624E-AE4C-DC4ED6BCAE17}" type="datetimeFigureOut">
               <a:rPr lang="en-US" smtClean="0"/>
-              <a:t>5/16/26</a:t>
+              <a:t>5/26/26</a:t>
             </a:fld>
             <a:endParaRPr lang="en-US"/>
           </a:p>
@@ -2355,7 +2355,7 @@
           <a:p>
             <a:fld id="{3E758BDC-CA1F-624E-AE4C-DC4ED6BCAE17}" type="datetimeFigureOut">
               <a:rPr lang="en-US" smtClean="0"/>
-              <a:t>5/16/26</a:t>
+              <a:t>5/26/26</a:t>
             </a:fld>
             <a:endParaRPr lang="en-US"/>
           </a:p>
@@ -2568,7 +2568,7 @@
           <a:p>
             <a:fld id="{3E758BDC-CA1F-624E-AE4C-DC4ED6BCAE17}" type="datetimeFigureOut">
               <a:rPr lang="en-US" smtClean="0"/>
-              <a:t>5/16/26</a:t>
+              <a:t>5/26/26</a:t>
             </a:fld>
             <a:endParaRPr lang="en-US"/>
           </a:p>
@@ -3154,7 +3154,7 @@
                 <a:latin typeface="Calibri" panose="020F0502020204030204" pitchFamily="34" charset="0"/>
                 <a:cs typeface="Calibri" panose="020F0502020204030204" pitchFamily="34" charset="0"/>
               </a:rPr>
-              <a:t>Check you program can run on GPUs and/or check for issues with your program regarding GPU use</a:t>
+              <a:t>Check your program can run on GPUs and/or check for issues with your program regarding GPU use</a:t>
             </a:r>
           </a:p>
         </p:txBody>
@@ -3367,7 +3367,21 @@
                 <a:latin typeface="Calibri" panose="020F0502020204030204" pitchFamily="34" charset="0"/>
                 <a:cs typeface="Calibri" panose="020F0502020204030204" pitchFamily="34" charset="0"/>
               </a:rPr>
-              <a:t>: Record your GPU utilization and GPU Memory usage, as well as how many “steps” your algorithm took (if possible, this is to measure job efficiently) </a:t>
+              <a:t>: Record your GPU </a:t>
+            </a:r>
+            <a:r>
+              <a:rPr lang="en-US" dirty="0" err="1">
+                <a:latin typeface="Calibri" panose="020F0502020204030204" pitchFamily="34" charset="0"/>
+                <a:cs typeface="Calibri" panose="020F0502020204030204" pitchFamily="34" charset="0"/>
+              </a:rPr>
+              <a:t>utilisation</a:t>
+            </a:r>
+            <a:r>
+              <a:rPr lang="en-US" dirty="0">
+                <a:latin typeface="Calibri" panose="020F0502020204030204" pitchFamily="34" charset="0"/>
+                <a:cs typeface="Calibri" panose="020F0502020204030204" pitchFamily="34" charset="0"/>
+              </a:rPr>
+              <a:t> and GPU Memory usage, as well as how many “steps” your algorithm took (if possible, this is to measure job efficiently) </a:t>
             </a:r>
           </a:p>
         </p:txBody>
@@ -3554,8 +3568,8 @@
         </p:nvSpPr>
         <p:spPr>
           <a:xfrm>
-            <a:off x="4364431" y="2997338"/>
-            <a:ext cx="3529192" cy="374435"/>
+            <a:off x="4364430" y="2997338"/>
+            <a:ext cx="3639363" cy="369332"/>
           </a:xfrm>
           <a:prstGeom prst="rect">
             <a:avLst/>
@@ -3601,7 +3615,7 @@
                 <a:latin typeface="Calibri" panose="020F0502020204030204" pitchFamily="34" charset="0"/>
                 <a:cs typeface="Calibri" panose="020F0502020204030204" pitchFamily="34" charset="0"/>
               </a:rPr>
-              <a:t>is the one to use, least wait time</a:t>
+              <a:t>is the GPU to use, least wait time</a:t>
             </a:r>
           </a:p>
         </p:txBody>
@@ -3941,7 +3955,21 @@
                 <a:latin typeface="Calibri" panose="020F0502020204030204" pitchFamily="34" charset="0"/>
                 <a:cs typeface="Calibri" panose="020F0502020204030204" pitchFamily="34" charset="0"/>
               </a:rPr>
-              <a:t>: Record your GPU utilization and GPU Memory usage, as well as how many “steps” your algorithm took (if possible, this is to measure job efficiently) </a:t>
+              <a:t>: Record your GPU </a:t>
+            </a:r>
+            <a:r>
+              <a:rPr lang="en-US" dirty="0" err="1">
+                <a:latin typeface="Calibri" panose="020F0502020204030204" pitchFamily="34" charset="0"/>
+                <a:cs typeface="Calibri" panose="020F0502020204030204" pitchFamily="34" charset="0"/>
+              </a:rPr>
+              <a:t>utilisation</a:t>
+            </a:r>
+            <a:r>
+              <a:rPr lang="en-US" dirty="0">
+                <a:latin typeface="Calibri" panose="020F0502020204030204" pitchFamily="34" charset="0"/>
+                <a:cs typeface="Calibri" panose="020F0502020204030204" pitchFamily="34" charset="0"/>
+              </a:rPr>
+              <a:t> and GPU Memory usage, as well as how many “steps” your algorithm took (if possible, this is to measure job efficiently) </a:t>
             </a:r>
           </a:p>
         </p:txBody>
@@ -4343,7 +4371,7 @@
                 <a:latin typeface="Calibri" panose="020F0502020204030204" pitchFamily="34" charset="0"/>
                 <a:cs typeface="Calibri" panose="020F0502020204030204" pitchFamily="34" charset="0"/>
               </a:rPr>
-              <a:t>is the one to use</a:t>
+              <a:t>is the GPU to use</a:t>
             </a:r>
           </a:p>
         </p:txBody>
@@ -5005,7 +5033,7 @@
         <p:spPr>
           <a:xfrm>
             <a:off x="5230034" y="12137958"/>
-            <a:ext cx="3632029" cy="369332"/>
+            <a:ext cx="3818247" cy="369332"/>
           </a:xfrm>
           <a:prstGeom prst="rect">
             <a:avLst/>
@@ -5051,7 +5079,7 @@
                 <a:latin typeface="Calibri" panose="020F0502020204030204" pitchFamily="34" charset="0"/>
                 <a:cs typeface="Calibri" panose="020F0502020204030204" pitchFamily="34" charset="0"/>
               </a:rPr>
-              <a:t>is the one to use</a:t>
+              <a:t>is the GPU to use</a:t>
             </a:r>
           </a:p>
         </p:txBody>
@@ -5071,7 +5099,7 @@
         <p:spPr>
           <a:xfrm>
             <a:off x="121856" y="13619176"/>
-            <a:ext cx="2339421" cy="369332"/>
+            <a:ext cx="2443923" cy="369332"/>
           </a:xfrm>
           <a:prstGeom prst="rect">
             <a:avLst/>
@@ -5103,7 +5131,7 @@
                 <a:latin typeface="Calibri" panose="020F0502020204030204" pitchFamily="34" charset="0"/>
                 <a:cs typeface="Calibri" panose="020F0502020204030204" pitchFamily="34" charset="0"/>
               </a:rPr>
-              <a:t>H100 is the one to use</a:t>
+              <a:t>H100 is the GPU to use</a:t>
             </a:r>
           </a:p>
         </p:txBody>

</xml_diff>